<commit_message>
fixed the docs and added langfuse
</commit_message>
<xml_diff>
--- a/study/presentation.pptx
+++ b/study/presentation.pptx
@@ -24,6 +24,8 @@
     <p:sldId id="272" r:id="rId23"/>
     <p:sldId id="273" r:id="rId24"/>
     <p:sldId id="274" r:id="rId25"/>
+    <p:sldId id="275" r:id="rId26"/>
+    <p:sldId id="276" r:id="rId27"/>
   </p:sldIdLst>
   <p:sldSz cx="12191695" cy="6858000" type="screen4x3"/>
   <p:notesSz cx="6858000" cy="9144000"/>
@@ -3428,7 +3430,7 @@
                 </a:solidFill>
                 <a:latin typeface="Calibri"/>
               </a:rPr>
-              <a:t>1 / 19</a:t>
+              <a:t>1 / 21</a:t>
             </a:r>
           </a:p>
         </p:txBody>
@@ -3789,7 +3791,7 @@
                 </a:solidFill>
                 <a:latin typeface="Calibri"/>
               </a:rPr>
-              <a:t>10 / 19</a:t>
+              <a:t>10 / 21</a:t>
             </a:r>
           </a:p>
         </p:txBody>
@@ -4134,7 +4136,7 @@
                 </a:solidFill>
                 <a:latin typeface="Calibri"/>
               </a:rPr>
-              <a:t>11 / 19</a:t>
+              <a:t>11 / 21</a:t>
             </a:r>
           </a:p>
         </p:txBody>
@@ -4230,7 +4232,7 @@
                 </a:solidFill>
                 <a:latin typeface="Calibri"/>
               </a:rPr>
-              <a:t>ABLATION TOOLING</a:t>
+              <a:t>TOOLING</a:t>
             </a:r>
           </a:p>
         </p:txBody>
@@ -4264,7 +4266,7 @@
                 </a:solidFill>
                 <a:latin typeface="Calibri"/>
               </a:rPr>
-              <a:t>CLI harness exposing every config knob</a:t>
+              <a:t>phonebot CLI: one entry point, every config knob</a:t>
             </a:r>
           </a:p>
         </p:txBody>
@@ -4320,8 +4322,8 @@
         </p:nvSpPr>
         <p:spPr>
           <a:xfrm>
-            <a:off x="548640" y="1645920"/>
-            <a:ext cx="10972800" cy="2286000"/>
+            <a:off x="548640" y="1554480"/>
+            <a:ext cx="10972800" cy="2377440"/>
           </a:xfrm>
           <a:prstGeom prst="rect">
             <a:avLst/>
@@ -4340,13 +4342,13 @@
               </a:spcAft>
             </a:pPr>
             <a:r>
-              <a:rPr sz="1800">
+              <a:rPr sz="1600">
                 <a:solidFill>
                   <a:srgbClr val="222B35"/>
                 </a:solidFill>
                 <a:latin typeface="Calibri"/>
               </a:rPr>
-              <a:t>•  study/cli.py mutates src.config before main.py is imported</a:t>
+              <a:t>•  phonebot run                  - batch over data/recordings/</a:t>
             </a:r>
           </a:p>
           <a:p>
@@ -4356,13 +4358,13 @@
               </a:spcAft>
             </a:pPr>
             <a:r>
-              <a:rPr sz="1800">
+              <a:rPr sz="1600">
                 <a:solidFill>
                   <a:srgbClr val="222B35"/>
                 </a:solidFill>
                 <a:latin typeface="Calibri"/>
               </a:rPr>
-              <a:t>•  Every relevant constant in src/config.py becomes a flag</a:t>
+              <a:t>•  phonebot extract &lt;wav&gt;        - one recording -&gt; JSON</a:t>
             </a:r>
           </a:p>
           <a:p>
@@ -4372,13 +4374,45 @@
               </a:spcAft>
             </a:pPr>
             <a:r>
-              <a:rPr sz="1800">
+              <a:rPr sz="1600">
                 <a:solidFill>
                   <a:srgbClr val="222B35"/>
                 </a:solidFill>
                 <a:latin typeface="Calibri"/>
               </a:rPr>
-              <a:t>•  Tagged reports go to study/results/ for aggregation</a:t>
+              <a:t>•  phonebot evaluate &lt;report&gt;    - re-evaluate against ground truth</a:t>
+            </a:r>
+          </a:p>
+          <a:p>
+            <a:pPr>
+              <a:spcAft>
+                <a:spcPts val="600"/>
+              </a:spcAft>
+            </a:pPr>
+            <a:r>
+              <a:rPr sz="1600">
+                <a:solidFill>
+                  <a:srgbClr val="222B35"/>
+                </a:solidFill>
+                <a:latin typeface="Calibri"/>
+              </a:rPr>
+              <a:t>•  phonebot ablate &lt;flags&gt;       - ablation run, every config knob exposed</a:t>
+            </a:r>
+          </a:p>
+          <a:p>
+            <a:pPr>
+              <a:spcAft>
+                <a:spcPts val="600"/>
+              </a:spcAft>
+            </a:pPr>
+            <a:r>
+              <a:rPr sz="1600">
+                <a:solidFill>
+                  <a:srgbClr val="222B35"/>
+                </a:solidFill>
+                <a:latin typeface="Calibri"/>
+              </a:rPr>
+              <a:t>•  phonebot doctor               - GPU / API / Langfuse status</a:t>
             </a:r>
           </a:p>
         </p:txBody>
@@ -4391,8 +4425,8 @@
         </p:nvSpPr>
         <p:spPr>
           <a:xfrm>
-            <a:off x="548640" y="3200400"/>
-            <a:ext cx="10972800" cy="2560320"/>
+            <a:off x="548640" y="3931920"/>
+            <a:ext cx="10972800" cy="2377440"/>
           </a:xfrm>
           <a:prstGeom prst="rect">
             <a:avLst/>
@@ -4406,13 +4440,13 @@
           <a:lstStyle/>
           <a:p>
             <a:r>
-              <a:rPr sz="1600">
+              <a:rPr sz="1500">
                 <a:solidFill>
                   <a:srgbClr val="222B35"/>
                 </a:solidFill>
                 <a:latin typeface="Consolas"/>
               </a:rPr>
-              <a:t>python -m study.cli \
+              <a:t>phonebot ablate \
     --transcription elevenlabs:scribe_v2 \
     --instruct "" --timestamp "" \
     --no-targeted --no-auto-resume \
@@ -4485,7 +4519,7 @@
                 </a:solidFill>
                 <a:latin typeface="Calibri"/>
               </a:rPr>
-              <a:t>12 / 19</a:t>
+              <a:t>12 / 21</a:t>
             </a:r>
           </a:p>
         </p:txBody>
@@ -4856,7 +4890,7 @@
                           </a:solidFill>
                           <a:latin typeface="Calibri"/>
                         </a:rPr>
-                        <a:t>best in 2 of 3 runs</a:t>
+                        <a:t>headline (Voxtral + Scribe + audio LLM + targeted)</a:t>
                       </a:r>
                     </a:p>
                   </a:txBody>
@@ -5509,7 +5543,7 @@
                 </a:solidFill>
                 <a:latin typeface="Calibri"/>
               </a:rPr>
-              <a:t>13 / 19</a:t>
+              <a:t>13 / 21</a:t>
             </a:r>
           </a:p>
         </p:txBody>
@@ -5775,7 +5809,7 @@
                 </a:solidFill>
                 <a:latin typeface="Calibri"/>
               </a:rPr>
-              <a:t>14 / 19</a:t>
+              <a:t>14 / 21</a:t>
             </a:r>
           </a:p>
         </p:txBody>
@@ -6041,7 +6075,7 @@
                 </a:solidFill>
                 <a:latin typeface="Calibri"/>
               </a:rPr>
-              <a:t>15 / 19</a:t>
+              <a:t>15 / 21</a:t>
             </a:r>
           </a:p>
         </p:txBody>
@@ -6342,7 +6376,7 @@
                 </a:solidFill>
                 <a:latin typeface="Calibri"/>
               </a:rPr>
-              <a:t>16 / 19</a:t>
+              <a:t>16 / 21</a:t>
             </a:r>
           </a:p>
         </p:txBody>
@@ -6667,7 +6701,7 @@
                 </a:solidFill>
                 <a:latin typeface="Calibri"/>
               </a:rPr>
-              <a:t>17 / 19</a:t>
+              <a:t>17 / 21</a:t>
             </a:r>
           </a:p>
         </p:txBody>
@@ -7012,7 +7046,7 @@
                 </a:solidFill>
                 <a:latin typeface="Calibri"/>
               </a:rPr>
-              <a:t>18 / 19</a:t>
+              <a:t>18 / 21</a:t>
             </a:r>
           </a:p>
         </p:txBody>
@@ -7108,7 +7142,7 @@
                 </a:solidFill>
                 <a:latin typeface="Calibri"/>
               </a:rPr>
-              <a:t>ERROR ANALYSIS &amp; CONCLUSION</a:t>
+              <a:t>EXTENSIBILITY</a:t>
             </a:r>
           </a:p>
         </p:txBody>
@@ -7142,7 +7176,7 @@
                 </a:solidFill>
                 <a:latin typeface="Calibri"/>
               </a:rPr>
-              <a:t>The one residual error mode</a:t>
+              <a:t>Adding a new entity is three small changes</a:t>
             </a:r>
           </a:p>
         </p:txBody>
@@ -7198,7 +7232,75 @@
         </p:nvSpPr>
         <p:spPr>
           <a:xfrm>
-            <a:off x="548640" y="1554480"/>
+            <a:off x="548640" y="1508760"/>
+            <a:ext cx="10972800" cy="365760"/>
+          </a:xfrm>
+          <a:prstGeom prst="rect">
+            <a:avLst/>
+          </a:prstGeom>
+          <a:noFill/>
+        </p:spPr>
+        <p:txBody>
+          <a:bodyPr wrap="square" lIns="0" rIns="0" tIns="0" bIns="0">
+            <a:spAutoFit/>
+          </a:bodyPr>
+          <a:lstStyle/>
+          <a:p>
+            <a:r>
+              <a:rPr sz="1400" b="0">
+                <a:solidFill>
+                  <a:srgbClr val="555F6B"/>
+                </a:solidFill>
+                <a:latin typeface="Calibri"/>
+              </a:rPr>
+              <a:t>Every layer is driven by one list:  KEYS = [...]  in src/config.py.</a:t>
+            </a:r>
+          </a:p>
+        </p:txBody>
+      </p:sp>
+      <p:sp>
+        <p:nvSpPr>
+          <p:cNvPr id="7" name="TextBox 6"/>
+          <p:cNvSpPr txBox="1"/>
+          <p:nvPr/>
+        </p:nvSpPr>
+        <p:spPr>
+          <a:xfrm>
+            <a:off x="548640" y="1965960"/>
+            <a:ext cx="10972800" cy="457200"/>
+          </a:xfrm>
+          <a:prstGeom prst="rect">
+            <a:avLst/>
+          </a:prstGeom>
+          <a:noFill/>
+        </p:spPr>
+        <p:txBody>
+          <a:bodyPr wrap="square" lIns="0" rIns="0" tIns="0" bIns="0">
+            <a:spAutoFit/>
+          </a:bodyPr>
+          <a:lstStyle/>
+          <a:p>
+            <a:r>
+              <a:rPr sz="1500" b="1">
+                <a:solidFill>
+                  <a:srgbClr val="222B35"/>
+                </a:solidFill>
+                <a:latin typeface="Calibri"/>
+              </a:rPr>
+              <a:t>To add company_name (or address, appointment_date, case_topic, ...):</a:t>
+            </a:r>
+          </a:p>
+        </p:txBody>
+      </p:sp>
+      <p:sp>
+        <p:nvSpPr>
+          <p:cNvPr id="8" name="TextBox 7"/>
+          <p:cNvSpPr txBox="1"/>
+          <p:nvPr/>
+        </p:nvSpPr>
+        <p:spPr>
+          <a:xfrm>
+            <a:off x="548640" y="2606040"/>
             <a:ext cx="10972800" cy="2286000"/>
           </a:xfrm>
           <a:prstGeom prst="rect">
@@ -7224,7 +7326,7 @@
                 </a:solidFill>
                 <a:latin typeface="Calibri"/>
               </a:rPr>
-              <a:t>•  call_23: emma.andersson@gmail.com - both STTs hear single 'n' (Anderson)</a:t>
+              <a:t>•  src/config.py: append the key to KEYS and add a &lt;KEY&gt;_RULES string describing how to extract it</a:t>
             </a:r>
           </a:p>
           <a:p>
@@ -7240,7 +7342,7 @@
                 </a:solidFill>
                 <a:latin typeface="Calibri"/>
               </a:rPr>
-              <a:t>•  Country detector identifies Swedish, but email piece is also 'anderson' so Net 4 cannot help</a:t>
+              <a:t>•  src/prompts.py: splice the new rule into EXTRACT_SYSTEM (and any other prompt that should know about it)</a:t>
             </a:r>
           </a:p>
           <a:p>
@@ -7256,21 +7358,21 @@
                 </a:solidFill>
                 <a:latin typeface="Calibri"/>
               </a:rPr>
-              <a:t>•  Fix: Swedish surname suffix prior, or sub-second re-listen on the ambiguous consonant</a:t>
-            </a:r>
-          </a:p>
-        </p:txBody>
-      </p:sp>
-      <p:sp>
-        <p:nvSpPr>
-          <p:cNvPr id="7" name="TextBox 6"/>
+              <a:t>•  src/schema.py: add the field to the CallerInfo Pydantic model (with an optional normaliser)</a:t>
+            </a:r>
+          </a:p>
+        </p:txBody>
+      </p:sp>
+      <p:sp>
+        <p:nvSpPr>
+          <p:cNvPr id="9" name="TextBox 8"/>
           <p:cNvSpPr txBox="1"/>
           <p:nvPr/>
         </p:nvSpPr>
         <p:spPr>
           <a:xfrm>
-            <a:off x="548640" y="4297680"/>
-            <a:ext cx="10972800" cy="457200"/>
+            <a:off x="548640" y="4617720"/>
+            <a:ext cx="10972800" cy="365760"/>
           </a:xfrm>
           <a:prstGeom prst="rect">
             <a:avLst/>
@@ -7284,27 +7386,27 @@
           <a:lstStyle/>
           <a:p>
             <a:r>
-              <a:rPr sz="2200" b="1">
-                <a:solidFill>
-                  <a:srgbClr val="0B3D91"/>
-                </a:solidFill>
-                <a:latin typeface="Calibri"/>
-              </a:rPr>
-              <a:t>Conclusion</a:t>
-            </a:r>
-          </a:p>
-        </p:txBody>
-      </p:sp>
-      <p:sp>
-        <p:nvSpPr>
-          <p:cNvPr id="8" name="TextBox 7"/>
+              <a:rPr sz="1500" b="1">
+                <a:solidFill>
+                  <a:srgbClr val="222B35"/>
+                </a:solidFill>
+                <a:latin typeface="Calibri"/>
+              </a:rPr>
+              <a:t>Everything else picks it up automatically:</a:t>
+            </a:r>
+          </a:p>
+        </p:txBody>
+      </p:sp>
+      <p:sp>
+        <p:nvSpPr>
+          <p:cNvPr id="10" name="TextBox 9"/>
           <p:cNvSpPr txBox="1"/>
           <p:nvPr/>
         </p:nvSpPr>
         <p:spPr>
           <a:xfrm>
-            <a:off x="548640" y="4754880"/>
-            <a:ext cx="10972800" cy="1828800"/>
+            <a:off x="548640" y="5074920"/>
+            <a:ext cx="10972800" cy="1463040"/>
           </a:xfrm>
           <a:prstGeom prst="rect">
             <a:avLst/>
@@ -7323,13 +7425,13 @@
               </a:spcAft>
             </a:pPr>
             <a:r>
-              <a:rPr sz="1700">
+              <a:rPr sz="1500">
                 <a:solidFill>
                   <a:srgbClr val="222B35"/>
                 </a:solidFill>
                 <a:latin typeface="Calibri"/>
               </a:rPr>
-              <a:t>•  Best run reaches 29/30 full-record matches (96.7%)</a:t>
+              <a:t>•  Layer 3 majority_vote already iterates KEYS  -&gt;  self-consistency for free</a:t>
             </a:r>
           </a:p>
           <a:p>
@@ -7339,13 +7441,13 @@
               </a:spcAft>
             </a:pPr>
             <a:r>
-              <a:rPr sz="1700">
+              <a:rPr sz="1500">
                 <a:solidFill>
                   <a:srgbClr val="222B35"/>
                 </a:solidFill>
                 <a:latin typeface="Calibri"/>
               </a:rPr>
-              <a:t>•  Per-key accuracy: 100% phone, 100% first name, 96.7% email + last name on the best run</a:t>
+              <a:t>•  Reconciler safety nets (Net 2 unanimous, Net 3 strict-majority) operate on every key in KEYS  -&gt;  no code change</a:t>
             </a:r>
           </a:p>
           <a:p>
@@ -7355,20 +7457,36 @@
               </a:spcAft>
             </a:pPr>
             <a:r>
-              <a:rPr sz="1700">
+              <a:rPr sz="1500">
                 <a:solidFill>
                   <a:srgbClr val="222B35"/>
                 </a:solidFill>
                 <a:latin typeface="Calibri"/>
               </a:rPr>
-              <a:t>•  Code, paper, ablation tooling, and reports all reproducible from the study/ folder</a:t>
-            </a:r>
-          </a:p>
-        </p:txBody>
-      </p:sp>
-      <p:sp>
-        <p:nvSpPr>
-          <p:cNvPr id="9" name="TextBox 8"/>
+              <a:t>•  Schema validator + evaluator share validators.py  -&gt;  prediction and ground truth normalised the same way</a:t>
+            </a:r>
+          </a:p>
+          <a:p>
+            <a:pPr>
+              <a:spcAft>
+                <a:spcPts val="600"/>
+              </a:spcAft>
+            </a:pPr>
+            <a:r>
+              <a:rPr sz="1500">
+                <a:solidFill>
+                  <a:srgbClr val="222B35"/>
+                </a:solidFill>
+                <a:latin typeface="Calibri"/>
+              </a:rPr>
+              <a:t>•  Langfuse traces auto-include the new field in every layer's output payload</a:t>
+            </a:r>
+          </a:p>
+        </p:txBody>
+      </p:sp>
+      <p:sp>
+        <p:nvSpPr>
+          <p:cNvPr id="11" name="TextBox 10"/>
           <p:cNvSpPr txBox="1"/>
           <p:nvPr/>
         </p:nvSpPr>
@@ -7402,7 +7520,7 @@
       </p:sp>
       <p:sp>
         <p:nvSpPr>
-          <p:cNvPr id="10" name="TextBox 9"/>
+          <p:cNvPr id="12" name="TextBox 11"/>
           <p:cNvSpPr txBox="1"/>
           <p:nvPr/>
         </p:nvSpPr>
@@ -7430,7 +7548,7 @@
                 </a:solidFill>
                 <a:latin typeface="Calibri"/>
               </a:rPr>
-              <a:t>19 / 19</a:t>
+              <a:t>19 / 21</a:t>
             </a:r>
           </a:p>
         </p:txBody>
@@ -7759,7 +7877,802 @@
                 </a:solidFill>
                 <a:latin typeface="Calibri"/>
               </a:rPr>
-              <a:t>2 / 19</a:t>
+              <a:t>2 / 21</a:t>
+            </a:r>
+          </a:p>
+        </p:txBody>
+      </p:sp>
+    </p:spTree>
+  </p:cSld>
+  <p:clrMapOvr>
+    <a:masterClrMapping/>
+  </p:clrMapOvr>
+</p:sld>
+</file>
+
+<file path=ppt/slides/slide20.xml><?xml version="1.0" encoding="utf-8"?>
+<p:sld xmlns:a="http://schemas.openxmlformats.org/drawingml/2006/main" xmlns:p="http://schemas.openxmlformats.org/presentationml/2006/main" xmlns:r="http://schemas.openxmlformats.org/officeDocument/2006/relationships">
+  <p:cSld>
+    <p:spTree>
+      <p:nvGrpSpPr>
+        <p:cNvPr id="1" name=""/>
+        <p:cNvGrpSpPr/>
+        <p:nvPr/>
+      </p:nvGrpSpPr>
+      <p:grpSpPr/>
+      <p:sp>
+        <p:nvSpPr>
+          <p:cNvPr id="2" name="Rectangle 1"/>
+          <p:cNvSpPr/>
+          <p:nvPr/>
+        </p:nvSpPr>
+        <p:spPr>
+          <a:xfrm>
+            <a:off x="0" y="0"/>
+            <a:ext cx="12191695" cy="6858000"/>
+          </a:xfrm>
+          <a:prstGeom prst="rect">
+            <a:avLst/>
+          </a:prstGeom>
+          <a:solidFill>
+            <a:srgbClr val="FAFBFD"/>
+          </a:solidFill>
+          <a:ln>
+            <a:noFill/>
+          </a:ln>
+          <a:effectLst/>
+        </p:spPr>
+        <p:style>
+          <a:lnRef idx="1">
+            <a:schemeClr val="accent1"/>
+          </a:lnRef>
+          <a:fillRef idx="3">
+            <a:schemeClr val="accent1"/>
+          </a:fillRef>
+          <a:effectRef idx="2">
+            <a:schemeClr val="accent1"/>
+          </a:effectRef>
+          <a:fontRef idx="minor">
+            <a:schemeClr val="lt1"/>
+          </a:fontRef>
+        </p:style>
+        <p:txBody>
+          <a:bodyPr rtlCol="0" anchor="ctr"/>
+          <a:lstStyle/>
+          <a:p>
+            <a:pPr algn="ctr"/>
+          </a:p>
+        </p:txBody>
+      </p:sp>
+      <p:sp>
+        <p:nvSpPr>
+          <p:cNvPr id="3" name="TextBox 2"/>
+          <p:cNvSpPr txBox="1"/>
+          <p:nvPr/>
+        </p:nvSpPr>
+        <p:spPr>
+          <a:xfrm>
+            <a:off x="548640" y="320040"/>
+            <a:ext cx="10972800" cy="365760"/>
+          </a:xfrm>
+          <a:prstGeom prst="rect">
+            <a:avLst/>
+          </a:prstGeom>
+          <a:noFill/>
+        </p:spPr>
+        <p:txBody>
+          <a:bodyPr wrap="square" lIns="0" rIns="0" tIns="0" bIns="0">
+            <a:spAutoFit/>
+          </a:bodyPr>
+          <a:lstStyle/>
+          <a:p>
+            <a:r>
+              <a:rPr sz="1200" b="1">
+                <a:solidFill>
+                  <a:srgbClr val="0B3D91"/>
+                </a:solidFill>
+                <a:latin typeface="Calibri"/>
+              </a:rPr>
+              <a:t>FUTURE IMPROVEMENTS</a:t>
+            </a:r>
+          </a:p>
+        </p:txBody>
+      </p:sp>
+      <p:sp>
+        <p:nvSpPr>
+          <p:cNvPr id="4" name="TextBox 3"/>
+          <p:cNvSpPr txBox="1"/>
+          <p:nvPr/>
+        </p:nvSpPr>
+        <p:spPr>
+          <a:xfrm>
+            <a:off x="548640" y="640080"/>
+            <a:ext cx="10972800" cy="640080"/>
+          </a:xfrm>
+          <a:prstGeom prst="rect">
+            <a:avLst/>
+          </a:prstGeom>
+          <a:noFill/>
+        </p:spPr>
+        <p:txBody>
+          <a:bodyPr wrap="square" lIns="0" rIns="0" tIns="0" bIns="0">
+            <a:spAutoFit/>
+          </a:bodyPr>
+          <a:lstStyle/>
+          <a:p>
+            <a:r>
+              <a:rPr sz="2800" b="1">
+                <a:solidFill>
+                  <a:srgbClr val="222B35"/>
+                </a:solidFill>
+                <a:latin typeface="Calibri"/>
+              </a:rPr>
+              <a:t>Where this goes next, in production</a:t>
+            </a:r>
+          </a:p>
+        </p:txBody>
+      </p:sp>
+      <p:sp>
+        <p:nvSpPr>
+          <p:cNvPr id="5" name="Rectangle 4"/>
+          <p:cNvSpPr/>
+          <p:nvPr/>
+        </p:nvSpPr>
+        <p:spPr>
+          <a:xfrm>
+            <a:off x="548640" y="1307592"/>
+            <a:ext cx="2286000" cy="25400"/>
+          </a:xfrm>
+          <a:prstGeom prst="rect">
+            <a:avLst/>
+          </a:prstGeom>
+          <a:solidFill>
+            <a:srgbClr val="0B3D91"/>
+          </a:solidFill>
+          <a:ln>
+            <a:noFill/>
+          </a:ln>
+        </p:spPr>
+        <p:style>
+          <a:lnRef idx="1">
+            <a:schemeClr val="accent1"/>
+          </a:lnRef>
+          <a:fillRef idx="3">
+            <a:schemeClr val="accent1"/>
+          </a:fillRef>
+          <a:effectRef idx="2">
+            <a:schemeClr val="accent1"/>
+          </a:effectRef>
+          <a:fontRef idx="minor">
+            <a:schemeClr val="lt1"/>
+          </a:fontRef>
+        </p:style>
+        <p:txBody>
+          <a:bodyPr rtlCol="0" anchor="ctr"/>
+          <a:lstStyle/>
+          <a:p>
+            <a:pPr algn="ctr"/>
+          </a:p>
+        </p:txBody>
+      </p:sp>
+      <p:sp>
+        <p:nvSpPr>
+          <p:cNvPr id="6" name="TextBox 5"/>
+          <p:cNvSpPr txBox="1"/>
+          <p:nvPr/>
+        </p:nvSpPr>
+        <p:spPr>
+          <a:xfrm>
+            <a:off x="548640" y="1554480"/>
+            <a:ext cx="10972800" cy="4754880"/>
+          </a:xfrm>
+          <a:prstGeom prst="rect">
+            <a:avLst/>
+          </a:prstGeom>
+          <a:noFill/>
+        </p:spPr>
+        <p:txBody>
+          <a:bodyPr wrap="square" lIns="0" rIns="0" tIns="0" bIns="0">
+            <a:spAutoFit/>
+          </a:bodyPr>
+          <a:lstStyle/>
+          <a:p>
+            <a:pPr>
+              <a:spcAft>
+                <a:spcPts val="600"/>
+              </a:spcAft>
+            </a:pPr>
+            <a:r>
+              <a:rPr sz="1500">
+                <a:solidFill>
+                  <a:srgbClr val="222B35"/>
+                </a:solidFill>
+                <a:latin typeface="Calibri"/>
+              </a:rPr>
+              <a:t>•  Real-time streaming: extract fields incrementally as the caller speaks, not after the call ends</a:t>
+            </a:r>
+          </a:p>
+          <a:p>
+            <a:pPr>
+              <a:spcAft>
+                <a:spcPts val="600"/>
+              </a:spcAft>
+            </a:pPr>
+            <a:r>
+              <a:rPr sz="1500">
+                <a:solidFill>
+                  <a:srgbClr val="222B35"/>
+                </a:solidFill>
+                <a:latin typeface="Calibri"/>
+              </a:rPr>
+              <a:t>•  TTS-driven clarification: when confidence is low, ask the caller ("M-U-E-L-L-E-R or M-U with umlaut?") instead of guessing</a:t>
+            </a:r>
+          </a:p>
+          <a:p>
+            <a:pPr>
+              <a:spcAft>
+                <a:spcPts val="600"/>
+              </a:spcAft>
+            </a:pPr>
+            <a:r>
+              <a:rPr sz="1500">
+                <a:solidFill>
+                  <a:srgbClr val="222B35"/>
+                </a:solidFill>
+                <a:latin typeface="Calibri"/>
+              </a:rPr>
+              <a:t>•  Adaptive memory + dynamic keyterms: confirmed tokens get stored and biased into the next turn's prompts</a:t>
+            </a:r>
+          </a:p>
+          <a:p>
+            <a:pPr>
+              <a:spcAft>
+                <a:spcPts val="600"/>
+              </a:spcAft>
+            </a:pPr>
+            <a:r>
+              <a:rPr sz="1500">
+                <a:solidFill>
+                  <a:srgbClr val="222B35"/>
+                </a:solidFill>
+                <a:latin typeface="Calibri"/>
+              </a:rPr>
+              <a:t>•  Multilingual: swap the language code; localise the spelling-marker word lists (Punkt -&gt; piste / prik / ...)</a:t>
+            </a:r>
+          </a:p>
+          <a:p>
+            <a:pPr>
+              <a:spcAft>
+                <a:spcPts val="600"/>
+              </a:spcAft>
+            </a:pPr>
+            <a:r>
+              <a:rPr sz="1500">
+                <a:solidFill>
+                  <a:srgbClr val="222B35"/>
+                </a:solidFill>
+                <a:latin typeface="Calibri"/>
+              </a:rPr>
+              <a:t>•  Concurrent users (20+): vLLM continuous batching for the SpeechLM, ElevenLabs pool with per-tenant rate limiting</a:t>
+            </a:r>
+          </a:p>
+          <a:p>
+            <a:pPr>
+              <a:spcAft>
+                <a:spcPts val="600"/>
+              </a:spcAft>
+            </a:pPr>
+            <a:r>
+              <a:rPr sz="1500">
+                <a:solidFill>
+                  <a:srgbClr val="222B35"/>
+                </a:solidFill>
+                <a:latin typeface="Calibri"/>
+              </a:rPr>
+              <a:t>•  Smaller, faster models: Voxtral-Mini -&gt; smaller SpeechLM, gpt-5.4-mini -&gt; open model on vLLM, Whisper -&gt; distil-whisper</a:t>
+            </a:r>
+          </a:p>
+          <a:p>
+            <a:pPr>
+              <a:spcAft>
+                <a:spcPts val="600"/>
+              </a:spcAft>
+            </a:pPr>
+            <a:r>
+              <a:rPr sz="1500">
+                <a:solidFill>
+                  <a:srgbClr val="222B35"/>
+                </a:solidFill>
+                <a:latin typeface="Calibri"/>
+              </a:rPr>
+              <a:t>•  Long conversations: 30-60s chunked windows + incremental extraction; targeted re-listen already shows the pattern</a:t>
+            </a:r>
+          </a:p>
+        </p:txBody>
+      </p:sp>
+      <p:sp>
+        <p:nvSpPr>
+          <p:cNvPr id="7" name="TextBox 6"/>
+          <p:cNvSpPr txBox="1"/>
+          <p:nvPr/>
+        </p:nvSpPr>
+        <p:spPr>
+          <a:xfrm>
+            <a:off x="548640" y="6492240"/>
+            <a:ext cx="7315200" cy="274320"/>
+          </a:xfrm>
+          <a:prstGeom prst="rect">
+            <a:avLst/>
+          </a:prstGeom>
+          <a:noFill/>
+        </p:spPr>
+        <p:txBody>
+          <a:bodyPr wrap="square" lIns="0" rIns="0" tIns="0" bIns="0">
+            <a:spAutoFit/>
+          </a:bodyPr>
+          <a:lstStyle/>
+          <a:p>
+            <a:r>
+              <a:rPr sz="1000" b="0">
+                <a:solidFill>
+                  <a:srgbClr val="555F6B"/>
+                </a:solidFill>
+                <a:latin typeface="Calibri"/>
+              </a:rPr>
+              <a:t>Phonebot Caller-Info Pipeline  -  Melih Unsal  -  JUPUS</a:t>
+            </a:r>
+          </a:p>
+        </p:txBody>
+      </p:sp>
+      <p:sp>
+        <p:nvSpPr>
+          <p:cNvPr id="8" name="TextBox 7"/>
+          <p:cNvSpPr txBox="1"/>
+          <p:nvPr/>
+        </p:nvSpPr>
+        <p:spPr>
+          <a:xfrm>
+            <a:off x="10789920" y="6492240"/>
+            <a:ext cx="1280160" cy="274320"/>
+          </a:xfrm>
+          <a:prstGeom prst="rect">
+            <a:avLst/>
+          </a:prstGeom>
+          <a:noFill/>
+        </p:spPr>
+        <p:txBody>
+          <a:bodyPr wrap="square" lIns="0" rIns="0" tIns="0" bIns="0">
+            <a:spAutoFit/>
+          </a:bodyPr>
+          <a:lstStyle/>
+          <a:p>
+            <a:pPr algn="r"/>
+            <a:r>
+              <a:rPr sz="1000" b="0">
+                <a:solidFill>
+                  <a:srgbClr val="555F6B"/>
+                </a:solidFill>
+                <a:latin typeface="Calibri"/>
+              </a:rPr>
+              <a:t>20 / 21</a:t>
+            </a:r>
+          </a:p>
+        </p:txBody>
+      </p:sp>
+    </p:spTree>
+  </p:cSld>
+  <p:clrMapOvr>
+    <a:masterClrMapping/>
+  </p:clrMapOvr>
+</p:sld>
+</file>
+
+<file path=ppt/slides/slide21.xml><?xml version="1.0" encoding="utf-8"?>
+<p:sld xmlns:a="http://schemas.openxmlformats.org/drawingml/2006/main" xmlns:p="http://schemas.openxmlformats.org/presentationml/2006/main" xmlns:r="http://schemas.openxmlformats.org/officeDocument/2006/relationships">
+  <p:cSld>
+    <p:spTree>
+      <p:nvGrpSpPr>
+        <p:cNvPr id="1" name=""/>
+        <p:cNvGrpSpPr/>
+        <p:nvPr/>
+      </p:nvGrpSpPr>
+      <p:grpSpPr/>
+      <p:sp>
+        <p:nvSpPr>
+          <p:cNvPr id="2" name="Rectangle 1"/>
+          <p:cNvSpPr/>
+          <p:nvPr/>
+        </p:nvSpPr>
+        <p:spPr>
+          <a:xfrm>
+            <a:off x="0" y="0"/>
+            <a:ext cx="12191695" cy="6858000"/>
+          </a:xfrm>
+          <a:prstGeom prst="rect">
+            <a:avLst/>
+          </a:prstGeom>
+          <a:solidFill>
+            <a:srgbClr val="FAFBFD"/>
+          </a:solidFill>
+          <a:ln>
+            <a:noFill/>
+          </a:ln>
+          <a:effectLst/>
+        </p:spPr>
+        <p:style>
+          <a:lnRef idx="1">
+            <a:schemeClr val="accent1"/>
+          </a:lnRef>
+          <a:fillRef idx="3">
+            <a:schemeClr val="accent1"/>
+          </a:fillRef>
+          <a:effectRef idx="2">
+            <a:schemeClr val="accent1"/>
+          </a:effectRef>
+          <a:fontRef idx="minor">
+            <a:schemeClr val="lt1"/>
+          </a:fontRef>
+        </p:style>
+        <p:txBody>
+          <a:bodyPr rtlCol="0" anchor="ctr"/>
+          <a:lstStyle/>
+          <a:p>
+            <a:pPr algn="ctr"/>
+          </a:p>
+        </p:txBody>
+      </p:sp>
+      <p:sp>
+        <p:nvSpPr>
+          <p:cNvPr id="3" name="TextBox 2"/>
+          <p:cNvSpPr txBox="1"/>
+          <p:nvPr/>
+        </p:nvSpPr>
+        <p:spPr>
+          <a:xfrm>
+            <a:off x="548640" y="320040"/>
+            <a:ext cx="10972800" cy="365760"/>
+          </a:xfrm>
+          <a:prstGeom prst="rect">
+            <a:avLst/>
+          </a:prstGeom>
+          <a:noFill/>
+        </p:spPr>
+        <p:txBody>
+          <a:bodyPr wrap="square" lIns="0" rIns="0" tIns="0" bIns="0">
+            <a:spAutoFit/>
+          </a:bodyPr>
+          <a:lstStyle/>
+          <a:p>
+            <a:r>
+              <a:rPr sz="1200" b="1">
+                <a:solidFill>
+                  <a:srgbClr val="0B3D91"/>
+                </a:solidFill>
+                <a:latin typeface="Calibri"/>
+              </a:rPr>
+              <a:t>ERROR ANALYSIS &amp; CONCLUSION</a:t>
+            </a:r>
+          </a:p>
+        </p:txBody>
+      </p:sp>
+      <p:sp>
+        <p:nvSpPr>
+          <p:cNvPr id="4" name="TextBox 3"/>
+          <p:cNvSpPr txBox="1"/>
+          <p:nvPr/>
+        </p:nvSpPr>
+        <p:spPr>
+          <a:xfrm>
+            <a:off x="548640" y="640080"/>
+            <a:ext cx="10972800" cy="640080"/>
+          </a:xfrm>
+          <a:prstGeom prst="rect">
+            <a:avLst/>
+          </a:prstGeom>
+          <a:noFill/>
+        </p:spPr>
+        <p:txBody>
+          <a:bodyPr wrap="square" lIns="0" rIns="0" tIns="0" bIns="0">
+            <a:spAutoFit/>
+          </a:bodyPr>
+          <a:lstStyle/>
+          <a:p>
+            <a:r>
+              <a:rPr sz="2800" b="1">
+                <a:solidFill>
+                  <a:srgbClr val="222B35"/>
+                </a:solidFill>
+                <a:latin typeface="Calibri"/>
+              </a:rPr>
+              <a:t>The one residual error mode</a:t>
+            </a:r>
+          </a:p>
+        </p:txBody>
+      </p:sp>
+      <p:sp>
+        <p:nvSpPr>
+          <p:cNvPr id="5" name="Rectangle 4"/>
+          <p:cNvSpPr/>
+          <p:nvPr/>
+        </p:nvSpPr>
+        <p:spPr>
+          <a:xfrm>
+            <a:off x="548640" y="1307592"/>
+            <a:ext cx="2286000" cy="25400"/>
+          </a:xfrm>
+          <a:prstGeom prst="rect">
+            <a:avLst/>
+          </a:prstGeom>
+          <a:solidFill>
+            <a:srgbClr val="0B3D91"/>
+          </a:solidFill>
+          <a:ln>
+            <a:noFill/>
+          </a:ln>
+        </p:spPr>
+        <p:style>
+          <a:lnRef idx="1">
+            <a:schemeClr val="accent1"/>
+          </a:lnRef>
+          <a:fillRef idx="3">
+            <a:schemeClr val="accent1"/>
+          </a:fillRef>
+          <a:effectRef idx="2">
+            <a:schemeClr val="accent1"/>
+          </a:effectRef>
+          <a:fontRef idx="minor">
+            <a:schemeClr val="lt1"/>
+          </a:fontRef>
+        </p:style>
+        <p:txBody>
+          <a:bodyPr rtlCol="0" anchor="ctr"/>
+          <a:lstStyle/>
+          <a:p>
+            <a:pPr algn="ctr"/>
+          </a:p>
+        </p:txBody>
+      </p:sp>
+      <p:sp>
+        <p:nvSpPr>
+          <p:cNvPr id="6" name="TextBox 5"/>
+          <p:cNvSpPr txBox="1"/>
+          <p:nvPr/>
+        </p:nvSpPr>
+        <p:spPr>
+          <a:xfrm>
+            <a:off x="548640" y="1554480"/>
+            <a:ext cx="10972800" cy="2286000"/>
+          </a:xfrm>
+          <a:prstGeom prst="rect">
+            <a:avLst/>
+          </a:prstGeom>
+          <a:noFill/>
+        </p:spPr>
+        <p:txBody>
+          <a:bodyPr wrap="square" lIns="0" rIns="0" tIns="0" bIns="0">
+            <a:spAutoFit/>
+          </a:bodyPr>
+          <a:lstStyle/>
+          <a:p>
+            <a:pPr>
+              <a:spcAft>
+                <a:spcPts val="600"/>
+              </a:spcAft>
+            </a:pPr>
+            <a:r>
+              <a:rPr sz="1700">
+                <a:solidFill>
+                  <a:srgbClr val="222B35"/>
+                </a:solidFill>
+                <a:latin typeface="Calibri"/>
+              </a:rPr>
+              <a:t>•  call_23: emma.andersson@gmail.com - both STTs hear single 'n' (Anderson)</a:t>
+            </a:r>
+          </a:p>
+          <a:p>
+            <a:pPr>
+              <a:spcAft>
+                <a:spcPts val="600"/>
+              </a:spcAft>
+            </a:pPr>
+            <a:r>
+              <a:rPr sz="1700">
+                <a:solidFill>
+                  <a:srgbClr val="222B35"/>
+                </a:solidFill>
+                <a:latin typeface="Calibri"/>
+              </a:rPr>
+              <a:t>•  Country detector identifies Swedish, but email piece is also 'anderson' so Net 4 cannot help</a:t>
+            </a:r>
+          </a:p>
+          <a:p>
+            <a:pPr>
+              <a:spcAft>
+                <a:spcPts val="600"/>
+              </a:spcAft>
+            </a:pPr>
+            <a:r>
+              <a:rPr sz="1700">
+                <a:solidFill>
+                  <a:srgbClr val="222B35"/>
+                </a:solidFill>
+                <a:latin typeface="Calibri"/>
+              </a:rPr>
+              <a:t>•  Fix: Swedish surname suffix prior, or sub-second re-listen on the ambiguous consonant</a:t>
+            </a:r>
+          </a:p>
+        </p:txBody>
+      </p:sp>
+      <p:sp>
+        <p:nvSpPr>
+          <p:cNvPr id="7" name="TextBox 6"/>
+          <p:cNvSpPr txBox="1"/>
+          <p:nvPr/>
+        </p:nvSpPr>
+        <p:spPr>
+          <a:xfrm>
+            <a:off x="548640" y="4297680"/>
+            <a:ext cx="10972800" cy="457200"/>
+          </a:xfrm>
+          <a:prstGeom prst="rect">
+            <a:avLst/>
+          </a:prstGeom>
+          <a:noFill/>
+        </p:spPr>
+        <p:txBody>
+          <a:bodyPr wrap="square" lIns="0" rIns="0" tIns="0" bIns="0">
+            <a:spAutoFit/>
+          </a:bodyPr>
+          <a:lstStyle/>
+          <a:p>
+            <a:r>
+              <a:rPr sz="2200" b="1">
+                <a:solidFill>
+                  <a:srgbClr val="0B3D91"/>
+                </a:solidFill>
+                <a:latin typeface="Calibri"/>
+              </a:rPr>
+              <a:t>Conclusion</a:t>
+            </a:r>
+          </a:p>
+        </p:txBody>
+      </p:sp>
+      <p:sp>
+        <p:nvSpPr>
+          <p:cNvPr id="8" name="TextBox 7"/>
+          <p:cNvSpPr txBox="1"/>
+          <p:nvPr/>
+        </p:nvSpPr>
+        <p:spPr>
+          <a:xfrm>
+            <a:off x="548640" y="4754880"/>
+            <a:ext cx="10972800" cy="1828800"/>
+          </a:xfrm>
+          <a:prstGeom prst="rect">
+            <a:avLst/>
+          </a:prstGeom>
+          <a:noFill/>
+        </p:spPr>
+        <p:txBody>
+          <a:bodyPr wrap="square" lIns="0" rIns="0" tIns="0" bIns="0">
+            <a:spAutoFit/>
+          </a:bodyPr>
+          <a:lstStyle/>
+          <a:p>
+            <a:pPr>
+              <a:spcAft>
+                <a:spcPts val="600"/>
+              </a:spcAft>
+            </a:pPr>
+            <a:r>
+              <a:rPr sz="1700">
+                <a:solidFill>
+                  <a:srgbClr val="222B35"/>
+                </a:solidFill>
+                <a:latin typeface="Calibri"/>
+              </a:rPr>
+              <a:t>•  Best run reaches 29/30 full-record matches (96.7%)</a:t>
+            </a:r>
+          </a:p>
+          <a:p>
+            <a:pPr>
+              <a:spcAft>
+                <a:spcPts val="600"/>
+              </a:spcAft>
+            </a:pPr>
+            <a:r>
+              <a:rPr sz="1700">
+                <a:solidFill>
+                  <a:srgbClr val="222B35"/>
+                </a:solidFill>
+                <a:latin typeface="Calibri"/>
+              </a:rPr>
+              <a:t>•  Per-key accuracy: 100% phone, 100% first name, 96.7% email + last name on the best run</a:t>
+            </a:r>
+          </a:p>
+          <a:p>
+            <a:pPr>
+              <a:spcAft>
+                <a:spcPts val="600"/>
+              </a:spcAft>
+            </a:pPr>
+            <a:r>
+              <a:rPr sz="1700">
+                <a:solidFill>
+                  <a:srgbClr val="222B35"/>
+                </a:solidFill>
+                <a:latin typeface="Calibri"/>
+              </a:rPr>
+              <a:t>•  Code, paper, ablation tooling, and reports all reproducible from the study/ folder</a:t>
+            </a:r>
+          </a:p>
+        </p:txBody>
+      </p:sp>
+      <p:sp>
+        <p:nvSpPr>
+          <p:cNvPr id="9" name="TextBox 8"/>
+          <p:cNvSpPr txBox="1"/>
+          <p:nvPr/>
+        </p:nvSpPr>
+        <p:spPr>
+          <a:xfrm>
+            <a:off x="548640" y="6492240"/>
+            <a:ext cx="7315200" cy="274320"/>
+          </a:xfrm>
+          <a:prstGeom prst="rect">
+            <a:avLst/>
+          </a:prstGeom>
+          <a:noFill/>
+        </p:spPr>
+        <p:txBody>
+          <a:bodyPr wrap="square" lIns="0" rIns="0" tIns="0" bIns="0">
+            <a:spAutoFit/>
+          </a:bodyPr>
+          <a:lstStyle/>
+          <a:p>
+            <a:r>
+              <a:rPr sz="1000" b="0">
+                <a:solidFill>
+                  <a:srgbClr val="555F6B"/>
+                </a:solidFill>
+                <a:latin typeface="Calibri"/>
+              </a:rPr>
+              <a:t>Phonebot Caller-Info Pipeline  -  Melih Unsal  -  JUPUS</a:t>
+            </a:r>
+          </a:p>
+        </p:txBody>
+      </p:sp>
+      <p:sp>
+        <p:nvSpPr>
+          <p:cNvPr id="10" name="TextBox 9"/>
+          <p:cNvSpPr txBox="1"/>
+          <p:nvPr/>
+        </p:nvSpPr>
+        <p:spPr>
+          <a:xfrm>
+            <a:off x="10789920" y="6492240"/>
+            <a:ext cx="1280160" cy="274320"/>
+          </a:xfrm>
+          <a:prstGeom prst="rect">
+            <a:avLst/>
+          </a:prstGeom>
+          <a:noFill/>
+        </p:spPr>
+        <p:txBody>
+          <a:bodyPr wrap="square" lIns="0" rIns="0" tIns="0" bIns="0">
+            <a:spAutoFit/>
+          </a:bodyPr>
+          <a:lstStyle/>
+          <a:p>
+            <a:pPr algn="r"/>
+            <a:r>
+              <a:rPr sz="1000" b="0">
+                <a:solidFill>
+                  <a:srgbClr val="555F6B"/>
+                </a:solidFill>
+                <a:latin typeface="Calibri"/>
+              </a:rPr>
+              <a:t>21 / 21</a:t>
             </a:r>
           </a:p>
         </p:txBody>
@@ -8104,7 +9017,7 @@
                 </a:solidFill>
                 <a:latin typeface="Calibri"/>
               </a:rPr>
-              <a:t>3 / 19</a:t>
+              <a:t>3 / 21</a:t>
             </a:r>
           </a:p>
         </p:txBody>
@@ -8404,7 +9317,7 @@
                 </a:solidFill>
                 <a:latin typeface="Calibri"/>
               </a:rPr>
-              <a:t>4 / 19</a:t>
+              <a:t>4 / 21</a:t>
             </a:r>
           </a:p>
         </p:txBody>
@@ -8776,7 +9689,7 @@
                 </a:solidFill>
                 <a:latin typeface="Calibri"/>
               </a:rPr>
-              <a:t>5 / 19</a:t>
+              <a:t>5 / 21</a:t>
             </a:r>
           </a:p>
         </p:txBody>
@@ -9121,7 +10034,7 @@
                 </a:solidFill>
                 <a:latin typeface="Calibri"/>
               </a:rPr>
-              <a:t>6 / 19</a:t>
+              <a:t>6 / 21</a:t>
             </a:r>
           </a:p>
         </p:txBody>
@@ -9466,7 +10379,7 @@
                 </a:solidFill>
                 <a:latin typeface="Calibri"/>
               </a:rPr>
-              <a:t>7 / 19</a:t>
+              <a:t>7 / 21</a:t>
             </a:r>
           </a:p>
         </p:txBody>
@@ -9811,7 +10724,7 @@
                 </a:solidFill>
                 <a:latin typeface="Calibri"/>
               </a:rPr>
-              <a:t>8 / 19</a:t>
+              <a:t>8 / 21</a:t>
             </a:r>
           </a:p>
         </p:txBody>
@@ -10172,7 +11085,7 @@
                 </a:solidFill>
                 <a:latin typeface="Calibri"/>
               </a:rPr>
-              <a:t>9 / 19</a:t>
+              <a:t>9 / 21</a:t>
             </a:r>
           </a:p>
         </p:txBody>

</xml_diff>